<commit_message>
Fix header UX + PPTX layout overflow
SolarHeader: camera FOV 75 z=12 (sun smaller/ambient), sun pushed to
upper-left (-7,1,0), 4-layer corona, 1200-star starfield, particles
converge Sun→Earth, KAVACH text 54px centered (removed paddingLeft hack),
warm amber radial-gradient bg, mission-control grid overlay, SOL/EARTH
bottom data tags replacing floating debug labels.

PPTX: remove stat_card(sz=38) calls on 0.38-inch strip in slides 5+7
which caused text to overflow off-slide — replaced with simple rrect+tb
badges. Dashboard: remove auroraMode/kp props not accepted by IndiaMap.
</commit_message>
<xml_diff>
--- a/docs/KAVACH_FARAWAY2026_FINAL.pptx
+++ b/docs/KAVACH_FARAWAY2026_FINAL.pptx
@@ -13714,27 +13714,20 @@
         </p:nvSpPr>
         <p:spPr>
           <a:xfrm>
-            <a:off x="411480" y="6400800"/>
-            <a:ext cx="2743200" cy="347472"/>
+            <a:off x="411480" y="6345936"/>
+            <a:ext cx="2743200" cy="402336"/>
           </a:xfrm>
           <a:prstGeom prst="roundRect">
             <a:avLst/>
           </a:prstGeom>
           <a:solidFill>
-            <a:srgbClr val="081830"/>
+            <a:srgbClr val="020C1C"/>
           </a:solidFill>
           <a:ln w="12700">
             <a:solidFill>
-              <a:srgbClr val="002A44"/>
+              <a:srgbClr val="005538"/>
             </a:solidFill>
           </a:ln>
-          <a:effectLst>
-            <a:outerShdw blurRad="63500" dist="30000" dir="5400000" algn="ctr" rotWithShape="0">
-              <a:srgbClr val="000000">
-                <a:alpha val="28000"/>
-              </a:srgbClr>
-            </a:outerShdw>
-          </a:effectLst>
         </p:spPr>
         <p:style>
           <a:lnRef idx="1">
@@ -13766,29 +13759,29 @@
         </p:nvSpPr>
         <p:spPr>
           <a:xfrm>
-            <a:off x="521208" y="6492240"/>
-            <a:ext cx="2542032" cy="215432"/>
-          </a:xfrm>
-          <a:prstGeom prst="rect">
-            <a:avLst/>
-          </a:prstGeom>
-          <a:noFill/>
-        </p:spPr>
-        <p:txBody>
-          <a:bodyPr wrap="square">
-            <a:spAutoFit/>
-          </a:bodyPr>
-          <a:lstStyle/>
-          <a:p>
-            <a:pPr algn="ctr"/>
-            <a:r>
-              <a:rPr sz="3800" b="1" i="0">
+            <a:off x="539496" y="6437376"/>
+            <a:ext cx="777240" cy="237744"/>
+          </a:xfrm>
+          <a:prstGeom prst="rect">
+            <a:avLst/>
+          </a:prstGeom>
+          <a:noFill/>
+        </p:spPr>
+        <p:txBody>
+          <a:bodyPr wrap="square">
+            <a:spAutoFit/>
+          </a:bodyPr>
+          <a:lstStyle/>
+          <a:p>
+            <a:pPr algn="l"/>
+            <a:r>
+              <a:rPr sz="1000" b="1" i="0">
                 <a:solidFill>
                   <a:srgbClr val="00FF88"/>
                 </a:solidFill>
                 <a:latin typeface="Consolas"/>
               </a:rPr>
-              <a:t>Live  Vercel deploy</a:t>
+              <a:t>LIVE</a:t>
             </a:r>
           </a:p>
         </p:txBody>
@@ -13801,97 +13794,55 @@
         </p:nvSpPr>
         <p:spPr>
           <a:xfrm>
-            <a:off x="502920" y="6626656"/>
-            <a:ext cx="2578608" cy="121615"/>
-          </a:xfrm>
-          <a:prstGeom prst="rect">
-            <a:avLst/>
-          </a:prstGeom>
-          <a:noFill/>
-        </p:spPr>
-        <p:txBody>
-          <a:bodyPr wrap="square">
-            <a:spAutoFit/>
-          </a:bodyPr>
-          <a:lstStyle/>
-          <a:p>
-            <a:pPr algn="ctr"/>
-            <a:r>
-              <a:rPr sz="900" b="0" i="0">
+            <a:off x="1380744" y="6437376"/>
+            <a:ext cx="1719072" cy="237744"/>
+          </a:xfrm>
+          <a:prstGeom prst="rect">
+            <a:avLst/>
+          </a:prstGeom>
+          <a:noFill/>
+        </p:spPr>
+        <p:txBody>
+          <a:bodyPr wrap="square">
+            <a:spAutoFit/>
+          </a:bodyPr>
+          <a:lstStyle/>
+          <a:p>
+            <a:pPr algn="l"/>
+            <a:r>
+              <a:rPr sz="1000" b="0" i="0">
                 <a:solidFill>
                   <a:srgbClr val="6872A8"/>
                 </a:solidFill>
                 <a:latin typeface="Calibri Light"/>
               </a:rPr>
-              <a:t/>
-            </a:r>
-          </a:p>
-        </p:txBody>
-      </p:sp>
-      <p:sp>
-        <p:nvSpPr>
-          <p:cNvPr id="46" name="TextBox 45"/>
-          <p:cNvSpPr txBox="1"/>
-          <p:nvPr/>
-        </p:nvSpPr>
-        <p:spPr>
-          <a:xfrm>
-            <a:off x="502920" y="6419088"/>
-            <a:ext cx="2560320" cy="274320"/>
-          </a:xfrm>
-          <a:prstGeom prst="rect">
-            <a:avLst/>
-          </a:prstGeom>
-          <a:noFill/>
-        </p:spPr>
-        <p:txBody>
-          <a:bodyPr wrap="square">
-            <a:spAutoFit/>
-          </a:bodyPr>
-          <a:lstStyle/>
-          <a:p>
-            <a:pPr algn="ctr"/>
-            <a:r>
-              <a:rPr sz="1100" b="1" i="0">
-                <a:solidFill>
-                  <a:srgbClr val="00FF88"/>
-                </a:solidFill>
-                <a:latin typeface="Consolas"/>
-              </a:rPr>
-              <a:t>Live  Vercel deploy</a:t>
-            </a:r>
-          </a:p>
-        </p:txBody>
-      </p:sp>
-      <p:sp>
-        <p:nvSpPr>
-          <p:cNvPr id="47" name="Rounded Rectangle 46"/>
+              <a:t>Vercel deploy</a:t>
+            </a:r>
+          </a:p>
+        </p:txBody>
+      </p:sp>
+      <p:sp>
+        <p:nvSpPr>
+          <p:cNvPr id="46" name="Rounded Rectangle 45"/>
           <p:cNvSpPr/>
           <p:nvPr/>
         </p:nvSpPr>
         <p:spPr>
           <a:xfrm>
-            <a:off x="3355848" y="6400800"/>
-            <a:ext cx="2743200" cy="347472"/>
+            <a:off x="3355848" y="6345936"/>
+            <a:ext cx="2743200" cy="402336"/>
           </a:xfrm>
           <a:prstGeom prst="roundRect">
             <a:avLst/>
           </a:prstGeom>
           <a:solidFill>
-            <a:srgbClr val="081830"/>
+            <a:srgbClr val="020C1C"/>
           </a:solidFill>
           <a:ln w="12700">
             <a:solidFill>
-              <a:srgbClr val="002A44"/>
+              <a:srgbClr val="005538"/>
             </a:solidFill>
           </a:ln>
-          <a:effectLst>
-            <a:outerShdw blurRad="63500" dist="30000" dir="5400000" algn="ctr" rotWithShape="0">
-              <a:srgbClr val="000000">
-                <a:alpha val="28000"/>
-              </a:srgbClr>
-            </a:outerShdw>
-          </a:effectLst>
         </p:spPr>
         <p:style>
           <a:lnRef idx="1">
@@ -13917,138 +13868,96 @@
       </p:sp>
       <p:sp>
         <p:nvSpPr>
+          <p:cNvPr id="47" name="TextBox 46"/>
+          <p:cNvSpPr txBox="1"/>
+          <p:nvPr/>
+        </p:nvSpPr>
+        <p:spPr>
+          <a:xfrm>
+            <a:off x="3483864" y="6437376"/>
+            <a:ext cx="777240" cy="237744"/>
+          </a:xfrm>
+          <a:prstGeom prst="rect">
+            <a:avLst/>
+          </a:prstGeom>
+          <a:noFill/>
+        </p:spPr>
+        <p:txBody>
+          <a:bodyPr wrap="square">
+            <a:spAutoFit/>
+          </a:bodyPr>
+          <a:lstStyle/>
+          <a:p>
+            <a:pPr algn="l"/>
+            <a:r>
+              <a:rPr sz="1000" b="1" i="0">
+                <a:solidFill>
+                  <a:srgbClr val="00FF88"/>
+                </a:solidFill>
+                <a:latin typeface="Consolas"/>
+              </a:rPr>
+              <a:t>LIVE</a:t>
+            </a:r>
+          </a:p>
+        </p:txBody>
+      </p:sp>
+      <p:sp>
+        <p:nvSpPr>
           <p:cNvPr id="48" name="TextBox 47"/>
           <p:cNvSpPr txBox="1"/>
           <p:nvPr/>
         </p:nvSpPr>
         <p:spPr>
           <a:xfrm>
-            <a:off x="3465576" y="6492240"/>
-            <a:ext cx="2542032" cy="215432"/>
-          </a:xfrm>
-          <a:prstGeom prst="rect">
-            <a:avLst/>
-          </a:prstGeom>
-          <a:noFill/>
-        </p:spPr>
-        <p:txBody>
-          <a:bodyPr wrap="square">
-            <a:spAutoFit/>
-          </a:bodyPr>
-          <a:lstStyle/>
-          <a:p>
-            <a:pPr algn="ctr"/>
-            <a:r>
-              <a:rPr sz="3800" b="1" i="0">
-                <a:solidFill>
-                  <a:srgbClr val="00FF88"/>
-                </a:solidFill>
-                <a:latin typeface="Consolas"/>
-              </a:rPr>
-              <a:t>Live  Railway backend</a:t>
-            </a:r>
-          </a:p>
-        </p:txBody>
-      </p:sp>
-      <p:sp>
-        <p:nvSpPr>
-          <p:cNvPr id="49" name="TextBox 48"/>
-          <p:cNvSpPr txBox="1"/>
-          <p:nvPr/>
-        </p:nvSpPr>
-        <p:spPr>
-          <a:xfrm>
-            <a:off x="3447288" y="6626656"/>
-            <a:ext cx="2578608" cy="121615"/>
-          </a:xfrm>
-          <a:prstGeom prst="rect">
-            <a:avLst/>
-          </a:prstGeom>
-          <a:noFill/>
-        </p:spPr>
-        <p:txBody>
-          <a:bodyPr wrap="square">
-            <a:spAutoFit/>
-          </a:bodyPr>
-          <a:lstStyle/>
-          <a:p>
-            <a:pPr algn="ctr"/>
-            <a:r>
-              <a:rPr sz="900" b="0" i="0">
+            <a:off x="4325112" y="6437376"/>
+            <a:ext cx="1719072" cy="237744"/>
+          </a:xfrm>
+          <a:prstGeom prst="rect">
+            <a:avLst/>
+          </a:prstGeom>
+          <a:noFill/>
+        </p:spPr>
+        <p:txBody>
+          <a:bodyPr wrap="square">
+            <a:spAutoFit/>
+          </a:bodyPr>
+          <a:lstStyle/>
+          <a:p>
+            <a:pPr algn="l"/>
+            <a:r>
+              <a:rPr sz="1000" b="0" i="0">
                 <a:solidFill>
                   <a:srgbClr val="6872A8"/>
                 </a:solidFill>
                 <a:latin typeface="Calibri Light"/>
               </a:rPr>
-              <a:t/>
-            </a:r>
-          </a:p>
-        </p:txBody>
-      </p:sp>
-      <p:sp>
-        <p:nvSpPr>
-          <p:cNvPr id="50" name="TextBox 49"/>
-          <p:cNvSpPr txBox="1"/>
-          <p:nvPr/>
-        </p:nvSpPr>
-        <p:spPr>
-          <a:xfrm>
-            <a:off x="3447288" y="6419088"/>
-            <a:ext cx="2560320" cy="274320"/>
-          </a:xfrm>
-          <a:prstGeom prst="rect">
-            <a:avLst/>
-          </a:prstGeom>
-          <a:noFill/>
-        </p:spPr>
-        <p:txBody>
-          <a:bodyPr wrap="square">
-            <a:spAutoFit/>
-          </a:bodyPr>
-          <a:lstStyle/>
-          <a:p>
-            <a:pPr algn="ctr"/>
-            <a:r>
-              <a:rPr sz="1100" b="1" i="0">
-                <a:solidFill>
-                  <a:srgbClr val="00FF88"/>
-                </a:solidFill>
-                <a:latin typeface="Consolas"/>
-              </a:rPr>
-              <a:t>Live  Railway backend</a:t>
-            </a:r>
-          </a:p>
-        </p:txBody>
-      </p:sp>
-      <p:sp>
-        <p:nvSpPr>
-          <p:cNvPr id="51" name="Rounded Rectangle 50"/>
+              <a:t>Railway backend</a:t>
+            </a:r>
+          </a:p>
+        </p:txBody>
+      </p:sp>
+      <p:sp>
+        <p:nvSpPr>
+          <p:cNvPr id="49" name="Rounded Rectangle 48"/>
           <p:cNvSpPr/>
           <p:nvPr/>
         </p:nvSpPr>
         <p:spPr>
           <a:xfrm>
-            <a:off x="6300216" y="6400800"/>
-            <a:ext cx="2743200" cy="347472"/>
+            <a:off x="6300216" y="6345936"/>
+            <a:ext cx="2743200" cy="402336"/>
           </a:xfrm>
           <a:prstGeom prst="roundRect">
             <a:avLst/>
           </a:prstGeom>
           <a:solidFill>
-            <a:srgbClr val="081830"/>
+            <a:srgbClr val="020C1C"/>
           </a:solidFill>
           <a:ln w="12700">
             <a:solidFill>
-              <a:srgbClr val="002A44"/>
+              <a:srgbClr val="005538"/>
             </a:solidFill>
           </a:ln>
-          <a:effectLst>
-            <a:outerShdw blurRad="63500" dist="30000" dir="5400000" algn="ctr" rotWithShape="0">
-              <a:srgbClr val="000000">
-                <a:alpha val="28000"/>
-              </a:srgbClr>
-            </a:outerShdw>
-          </a:effectLst>
         </p:spPr>
         <p:style>
           <a:lnRef idx="1">
@@ -14074,138 +13983,96 @@
       </p:sp>
       <p:sp>
         <p:nvSpPr>
-          <p:cNvPr id="52" name="TextBox 51"/>
-          <p:cNvSpPr txBox="1"/>
-          <p:nvPr/>
-        </p:nvSpPr>
-        <p:spPr>
-          <a:xfrm>
-            <a:off x="6409944" y="6492240"/>
-            <a:ext cx="2542032" cy="215432"/>
-          </a:xfrm>
-          <a:prstGeom prst="rect">
-            <a:avLst/>
-          </a:prstGeom>
-          <a:noFill/>
-        </p:spPr>
-        <p:txBody>
-          <a:bodyPr wrap="square">
-            <a:spAutoFit/>
-          </a:bodyPr>
-          <a:lstStyle/>
-          <a:p>
-            <a:pPr algn="ctr"/>
-            <a:r>
-              <a:rPr sz="3800" b="1" i="0">
+          <p:cNvPr id="50" name="TextBox 49"/>
+          <p:cNvSpPr txBox="1"/>
+          <p:nvPr/>
+        </p:nvSpPr>
+        <p:spPr>
+          <a:xfrm>
+            <a:off x="6428232" y="6437376"/>
+            <a:ext cx="777240" cy="237744"/>
+          </a:xfrm>
+          <a:prstGeom prst="rect">
+            <a:avLst/>
+          </a:prstGeom>
+          <a:noFill/>
+        </p:spPr>
+        <p:txBody>
+          <a:bodyPr wrap="square">
+            <a:spAutoFit/>
+          </a:bodyPr>
+          <a:lstStyle/>
+          <a:p>
+            <a:pPr algn="l"/>
+            <a:r>
+              <a:rPr sz="1000" b="1" i="0">
                 <a:solidFill>
                   <a:srgbClr val="00FF88"/>
                 </a:solidFill>
                 <a:latin typeface="Consolas"/>
               </a:rPr>
-              <a:t>Live  Twilio tested</a:t>
-            </a:r>
-          </a:p>
-        </p:txBody>
-      </p:sp>
-      <p:sp>
-        <p:nvSpPr>
-          <p:cNvPr id="53" name="TextBox 52"/>
-          <p:cNvSpPr txBox="1"/>
-          <p:nvPr/>
-        </p:nvSpPr>
-        <p:spPr>
-          <a:xfrm>
-            <a:off x="6391656" y="6626656"/>
-            <a:ext cx="2578608" cy="121615"/>
-          </a:xfrm>
-          <a:prstGeom prst="rect">
-            <a:avLst/>
-          </a:prstGeom>
-          <a:noFill/>
-        </p:spPr>
-        <p:txBody>
-          <a:bodyPr wrap="square">
-            <a:spAutoFit/>
-          </a:bodyPr>
-          <a:lstStyle/>
-          <a:p>
-            <a:pPr algn="ctr"/>
-            <a:r>
-              <a:rPr sz="900" b="0" i="0">
+              <a:t>LIVE</a:t>
+            </a:r>
+          </a:p>
+        </p:txBody>
+      </p:sp>
+      <p:sp>
+        <p:nvSpPr>
+          <p:cNvPr id="51" name="TextBox 50"/>
+          <p:cNvSpPr txBox="1"/>
+          <p:nvPr/>
+        </p:nvSpPr>
+        <p:spPr>
+          <a:xfrm>
+            <a:off x="7269480" y="6437376"/>
+            <a:ext cx="1719072" cy="237744"/>
+          </a:xfrm>
+          <a:prstGeom prst="rect">
+            <a:avLst/>
+          </a:prstGeom>
+          <a:noFill/>
+        </p:spPr>
+        <p:txBody>
+          <a:bodyPr wrap="square">
+            <a:spAutoFit/>
+          </a:bodyPr>
+          <a:lstStyle/>
+          <a:p>
+            <a:pPr algn="l"/>
+            <a:r>
+              <a:rPr sz="1000" b="0" i="0">
                 <a:solidFill>
                   <a:srgbClr val="6872A8"/>
                 </a:solidFill>
                 <a:latin typeface="Calibri Light"/>
               </a:rPr>
-              <a:t/>
-            </a:r>
-          </a:p>
-        </p:txBody>
-      </p:sp>
-      <p:sp>
-        <p:nvSpPr>
-          <p:cNvPr id="54" name="TextBox 53"/>
-          <p:cNvSpPr txBox="1"/>
-          <p:nvPr/>
-        </p:nvSpPr>
-        <p:spPr>
-          <a:xfrm>
-            <a:off x="6391656" y="6419088"/>
-            <a:ext cx="2560320" cy="274320"/>
-          </a:xfrm>
-          <a:prstGeom prst="rect">
-            <a:avLst/>
-          </a:prstGeom>
-          <a:noFill/>
-        </p:spPr>
-        <p:txBody>
-          <a:bodyPr wrap="square">
-            <a:spAutoFit/>
-          </a:bodyPr>
-          <a:lstStyle/>
-          <a:p>
-            <a:pPr algn="ctr"/>
-            <a:r>
-              <a:rPr sz="1100" b="1" i="0">
-                <a:solidFill>
-                  <a:srgbClr val="00FF88"/>
-                </a:solidFill>
-                <a:latin typeface="Consolas"/>
-              </a:rPr>
-              <a:t>Live  Twilio tested</a:t>
-            </a:r>
-          </a:p>
-        </p:txBody>
-      </p:sp>
-      <p:sp>
-        <p:nvSpPr>
-          <p:cNvPr id="55" name="Rounded Rectangle 54"/>
+              <a:t>Twilio tested</a:t>
+            </a:r>
+          </a:p>
+        </p:txBody>
+      </p:sp>
+      <p:sp>
+        <p:nvSpPr>
+          <p:cNvPr id="52" name="Rounded Rectangle 51"/>
           <p:cNvSpPr/>
           <p:nvPr/>
         </p:nvSpPr>
         <p:spPr>
           <a:xfrm>
-            <a:off x="9244584" y="6400800"/>
-            <a:ext cx="2743200" cy="347472"/>
+            <a:off x="9244584" y="6345936"/>
+            <a:ext cx="2743200" cy="402336"/>
           </a:xfrm>
           <a:prstGeom prst="roundRect">
             <a:avLst/>
           </a:prstGeom>
           <a:solidFill>
-            <a:srgbClr val="081830"/>
+            <a:srgbClr val="020C1C"/>
           </a:solidFill>
           <a:ln w="12700">
             <a:solidFill>
-              <a:srgbClr val="002A44"/>
+              <a:srgbClr val="005C8A"/>
             </a:solidFill>
           </a:ln>
-          <a:effectLst>
-            <a:outerShdw blurRad="63500" dist="30000" dir="5400000" algn="ctr" rotWithShape="0">
-              <a:srgbClr val="000000">
-                <a:alpha val="28000"/>
-              </a:srgbClr>
-            </a:outerShdw>
-          </a:effectLst>
         </p:spPr>
         <p:style>
           <a:lnRef idx="1">
@@ -14231,112 +14098,77 @@
       </p:sp>
       <p:sp>
         <p:nvSpPr>
-          <p:cNvPr id="56" name="TextBox 55"/>
-          <p:cNvSpPr txBox="1"/>
-          <p:nvPr/>
-        </p:nvSpPr>
-        <p:spPr>
-          <a:xfrm>
-            <a:off x="9354311" y="6492240"/>
-            <a:ext cx="2542032" cy="215432"/>
-          </a:xfrm>
-          <a:prstGeom prst="rect">
-            <a:avLst/>
-          </a:prstGeom>
-          <a:noFill/>
-        </p:spPr>
-        <p:txBody>
-          <a:bodyPr wrap="square">
-            <a:spAutoFit/>
-          </a:bodyPr>
-          <a:lstStyle/>
-          <a:p>
-            <a:pPr algn="ctr"/>
-            <a:r>
-              <a:rPr sz="3800" b="1" i="0">
+          <p:cNvPr id="53" name="TextBox 52"/>
+          <p:cNvSpPr txBox="1"/>
+          <p:nvPr/>
+        </p:nvSpPr>
+        <p:spPr>
+          <a:xfrm>
+            <a:off x="9372600" y="6437376"/>
+            <a:ext cx="777240" cy="237744"/>
+          </a:xfrm>
+          <a:prstGeom prst="rect">
+            <a:avLst/>
+          </a:prstGeom>
+          <a:noFill/>
+        </p:spPr>
+        <p:txBody>
+          <a:bodyPr wrap="square">
+            <a:spAutoFit/>
+          </a:bodyPr>
+          <a:lstStyle/>
+          <a:p>
+            <a:pPr algn="l"/>
+            <a:r>
+              <a:rPr sz="1000" b="1" i="0">
                 <a:solidFill>
                   <a:srgbClr val="00D4FF"/>
                 </a:solidFill>
                 <a:latin typeface="Consolas"/>
               </a:rPr>
-              <a:t>6 days  Concept to ship</a:t>
-            </a:r>
-          </a:p>
-        </p:txBody>
-      </p:sp>
-      <p:sp>
-        <p:nvSpPr>
-          <p:cNvPr id="57" name="TextBox 56"/>
-          <p:cNvSpPr txBox="1"/>
-          <p:nvPr/>
-        </p:nvSpPr>
-        <p:spPr>
-          <a:xfrm>
-            <a:off x="9336024" y="6626656"/>
-            <a:ext cx="2578608" cy="121615"/>
-          </a:xfrm>
-          <a:prstGeom prst="rect">
-            <a:avLst/>
-          </a:prstGeom>
-          <a:noFill/>
-        </p:spPr>
-        <p:txBody>
-          <a:bodyPr wrap="square">
-            <a:spAutoFit/>
-          </a:bodyPr>
-          <a:lstStyle/>
-          <a:p>
-            <a:pPr algn="ctr"/>
-            <a:r>
-              <a:rPr sz="900" b="0" i="0">
+              <a:t>6 DAYS</a:t>
+            </a:r>
+          </a:p>
+        </p:txBody>
+      </p:sp>
+      <p:sp>
+        <p:nvSpPr>
+          <p:cNvPr id="54" name="TextBox 53"/>
+          <p:cNvSpPr txBox="1"/>
+          <p:nvPr/>
+        </p:nvSpPr>
+        <p:spPr>
+          <a:xfrm>
+            <a:off x="10213848" y="6437376"/>
+            <a:ext cx="1719072" cy="237744"/>
+          </a:xfrm>
+          <a:prstGeom prst="rect">
+            <a:avLst/>
+          </a:prstGeom>
+          <a:noFill/>
+        </p:spPr>
+        <p:txBody>
+          <a:bodyPr wrap="square">
+            <a:spAutoFit/>
+          </a:bodyPr>
+          <a:lstStyle/>
+          <a:p>
+            <a:pPr algn="l"/>
+            <a:r>
+              <a:rPr sz="1000" b="0" i="0">
                 <a:solidFill>
                   <a:srgbClr val="6872A8"/>
                 </a:solidFill>
                 <a:latin typeface="Calibri Light"/>
               </a:rPr>
-              <a:t/>
-            </a:r>
-          </a:p>
-        </p:txBody>
-      </p:sp>
-      <p:sp>
-        <p:nvSpPr>
-          <p:cNvPr id="58" name="TextBox 57"/>
-          <p:cNvSpPr txBox="1"/>
-          <p:nvPr/>
-        </p:nvSpPr>
-        <p:spPr>
-          <a:xfrm>
-            <a:off x="9336024" y="6419088"/>
-            <a:ext cx="2560320" cy="274320"/>
-          </a:xfrm>
-          <a:prstGeom prst="rect">
-            <a:avLst/>
-          </a:prstGeom>
-          <a:noFill/>
-        </p:spPr>
-        <p:txBody>
-          <a:bodyPr wrap="square">
-            <a:spAutoFit/>
-          </a:bodyPr>
-          <a:lstStyle/>
-          <a:p>
-            <a:pPr algn="ctr"/>
-            <a:r>
-              <a:rPr sz="1100" b="1" i="0">
-                <a:solidFill>
-                  <a:srgbClr val="00D4FF"/>
-                </a:solidFill>
-                <a:latin typeface="Consolas"/>
-              </a:rPr>
-              <a:t>6 days  Concept to ship</a:t>
-            </a:r>
-          </a:p>
-        </p:txBody>
-      </p:sp>
-      <p:sp>
-        <p:nvSpPr>
-          <p:cNvPr id="59" name="Rectangle 58"/>
+              <a:t>Concept to ship</a:t>
+            </a:r>
+          </a:p>
+        </p:txBody>
+      </p:sp>
+      <p:sp>
+        <p:nvSpPr>
+          <p:cNvPr id="55" name="Rectangle 54"/>
           <p:cNvSpPr/>
           <p:nvPr/>
         </p:nvSpPr>
@@ -18306,8 +18138,8 @@
         </p:nvSpPr>
         <p:spPr>
           <a:xfrm>
-            <a:off x="411480" y="6419088"/>
-            <a:ext cx="1965960" cy="347472"/>
+            <a:off x="411480" y="6400800"/>
+            <a:ext cx="1965960" cy="384048"/>
           </a:xfrm>
           <a:prstGeom prst="roundRect">
             <a:avLst/>
@@ -18320,13 +18152,6 @@
               <a:srgbClr val="002A44"/>
             </a:solidFill>
           </a:ln>
-          <a:effectLst>
-            <a:outerShdw blurRad="63500" dist="30000" dir="5400000" algn="ctr" rotWithShape="0">
-              <a:srgbClr val="000000">
-                <a:alpha val="28000"/>
-              </a:srgbClr>
-            </a:outerShdw>
-          </a:effectLst>
         </p:spPr>
         <p:style>
           <a:lnRef idx="1">
@@ -18358,29 +18183,29 @@
         </p:nvSpPr>
         <p:spPr>
           <a:xfrm>
-            <a:off x="521208" y="6510527"/>
-            <a:ext cx="1764792" cy="215432"/>
-          </a:xfrm>
-          <a:prstGeom prst="rect">
-            <a:avLst/>
-          </a:prstGeom>
-          <a:noFill/>
-        </p:spPr>
-        <p:txBody>
-          <a:bodyPr wrap="square">
-            <a:spAutoFit/>
-          </a:bodyPr>
-          <a:lstStyle/>
-          <a:p>
-            <a:pPr algn="ctr"/>
-            <a:r>
-              <a:rPr sz="3800" b="1" i="0">
+            <a:off x="521208" y="6473952"/>
+            <a:ext cx="749808" cy="237744"/>
+          </a:xfrm>
+          <a:prstGeom prst="rect">
+            <a:avLst/>
+          </a:prstGeom>
+          <a:noFill/>
+        </p:spPr>
+        <p:txBody>
+          <a:bodyPr wrap="square">
+            <a:spAutoFit/>
+          </a:bodyPr>
+          <a:lstStyle/>
+          <a:p>
+            <a:pPr algn="l"/>
+            <a:r>
+              <a:rPr sz="1100" b="1" i="0">
                 <a:solidFill>
                   <a:srgbClr val="FFD23F"/>
                 </a:solidFill>
                 <a:latin typeface="Consolas"/>
               </a:rPr>
-              <a:t>22.6s  demo runtime</a:t>
+              <a:t>22.6s</a:t>
             </a:r>
           </a:p>
         </p:txBody>
@@ -18393,21 +18218,21 @@
         </p:nvSpPr>
         <p:spPr>
           <a:xfrm>
-            <a:off x="502920" y="6644944"/>
-            <a:ext cx="1801368" cy="121615"/>
-          </a:xfrm>
-          <a:prstGeom prst="rect">
-            <a:avLst/>
-          </a:prstGeom>
-          <a:noFill/>
-        </p:spPr>
-        <p:txBody>
-          <a:bodyPr wrap="square">
-            <a:spAutoFit/>
-          </a:bodyPr>
-          <a:lstStyle/>
-          <a:p>
-            <a:pPr algn="ctr"/>
+            <a:off x="1307592" y="6473952"/>
+            <a:ext cx="1005840" cy="237744"/>
+          </a:xfrm>
+          <a:prstGeom prst="rect">
+            <a:avLst/>
+          </a:prstGeom>
+          <a:noFill/>
+        </p:spPr>
+        <p:txBody>
+          <a:bodyPr wrap="square">
+            <a:spAutoFit/>
+          </a:bodyPr>
+          <a:lstStyle/>
+          <a:p>
+            <a:pPr algn="l"/>
             <a:r>
               <a:rPr sz="900" b="0" i="0">
                 <a:solidFill>
@@ -18415,56 +18240,21 @@
                 </a:solidFill>
                 <a:latin typeface="Calibri Light"/>
               </a:rPr>
-              <a:t/>
-            </a:r>
-          </a:p>
-        </p:txBody>
-      </p:sp>
-      <p:sp>
-        <p:nvSpPr>
-          <p:cNvPr id="56" name="TextBox 55"/>
-          <p:cNvSpPr txBox="1"/>
-          <p:nvPr/>
-        </p:nvSpPr>
-        <p:spPr>
-          <a:xfrm>
-            <a:off x="484632" y="6446520"/>
-            <a:ext cx="1874519" cy="274320"/>
-          </a:xfrm>
-          <a:prstGeom prst="rect">
-            <a:avLst/>
-          </a:prstGeom>
-          <a:noFill/>
-        </p:spPr>
-        <p:txBody>
-          <a:bodyPr wrap="square">
-            <a:spAutoFit/>
-          </a:bodyPr>
-          <a:lstStyle/>
-          <a:p>
-            <a:pPr algn="ctr"/>
-            <a:r>
-              <a:rPr sz="1000" b="1" i="0">
-                <a:solidFill>
-                  <a:srgbClr val="FFD23F"/>
-                </a:solidFill>
-                <a:latin typeface="Consolas"/>
-              </a:rPr>
-              <a:t>22.6s  demo runtime</a:t>
-            </a:r>
-          </a:p>
-        </p:txBody>
-      </p:sp>
-      <p:sp>
-        <p:nvSpPr>
-          <p:cNvPr id="57" name="Rounded Rectangle 56"/>
+              <a:t>demo runtime</a:t>
+            </a:r>
+          </a:p>
+        </p:txBody>
+      </p:sp>
+      <p:sp>
+        <p:nvSpPr>
+          <p:cNvPr id="56" name="Rounded Rectangle 55"/>
           <p:cNvSpPr/>
           <p:nvPr/>
         </p:nvSpPr>
         <p:spPr>
           <a:xfrm>
-            <a:off x="2514600" y="6419088"/>
-            <a:ext cx="1965960" cy="347472"/>
+            <a:off x="2514600" y="6400800"/>
+            <a:ext cx="1965960" cy="384048"/>
           </a:xfrm>
           <a:prstGeom prst="roundRect">
             <a:avLst/>
@@ -18477,13 +18267,6 @@
               <a:srgbClr val="002A44"/>
             </a:solidFill>
           </a:ln>
-          <a:effectLst>
-            <a:outerShdw blurRad="63500" dist="30000" dir="5400000" algn="ctr" rotWithShape="0">
-              <a:srgbClr val="000000">
-                <a:alpha val="28000"/>
-              </a:srgbClr>
-            </a:outerShdw>
-          </a:effectLst>
         </p:spPr>
         <p:style>
           <a:lnRef idx="1">
@@ -18509,62 +18292,62 @@
       </p:sp>
       <p:sp>
         <p:nvSpPr>
+          <p:cNvPr id="57" name="TextBox 56"/>
+          <p:cNvSpPr txBox="1"/>
+          <p:nvPr/>
+        </p:nvSpPr>
+        <p:spPr>
+          <a:xfrm>
+            <a:off x="2624328" y="6473952"/>
+            <a:ext cx="749808" cy="237744"/>
+          </a:xfrm>
+          <a:prstGeom prst="rect">
+            <a:avLst/>
+          </a:prstGeom>
+          <a:noFill/>
+        </p:spPr>
+        <p:txBody>
+          <a:bodyPr wrap="square">
+            <a:spAutoFit/>
+          </a:bodyPr>
+          <a:lstStyle/>
+          <a:p>
+            <a:pPr algn="l"/>
+            <a:r>
+              <a:rPr sz="1100" b="1" i="0">
+                <a:solidFill>
+                  <a:srgbClr val="00D4FF"/>
+                </a:solidFill>
+                <a:latin typeface="Consolas"/>
+              </a:rPr>
+              <a:t>4.5h</a:t>
+            </a:r>
+          </a:p>
+        </p:txBody>
+      </p:sp>
+      <p:sp>
+        <p:nvSpPr>
           <p:cNvPr id="58" name="TextBox 57"/>
           <p:cNvSpPr txBox="1"/>
           <p:nvPr/>
         </p:nvSpPr>
         <p:spPr>
           <a:xfrm>
-            <a:off x="2624328" y="6510527"/>
-            <a:ext cx="1764792" cy="215432"/>
-          </a:xfrm>
-          <a:prstGeom prst="rect">
-            <a:avLst/>
-          </a:prstGeom>
-          <a:noFill/>
-        </p:spPr>
-        <p:txBody>
-          <a:bodyPr wrap="square">
-            <a:spAutoFit/>
-          </a:bodyPr>
-          <a:lstStyle/>
-          <a:p>
-            <a:pPr algn="ctr"/>
-            <a:r>
-              <a:rPr sz="3800" b="1" i="0">
-                <a:solidFill>
-                  <a:srgbClr val="00D4FF"/>
-                </a:solidFill>
-                <a:latin typeface="Consolas"/>
-              </a:rPr>
-              <a:t>4.5h  warning window</a:t>
-            </a:r>
-          </a:p>
-        </p:txBody>
-      </p:sp>
-      <p:sp>
-        <p:nvSpPr>
-          <p:cNvPr id="59" name="TextBox 58"/>
-          <p:cNvSpPr txBox="1"/>
-          <p:nvPr/>
-        </p:nvSpPr>
-        <p:spPr>
-          <a:xfrm>
-            <a:off x="2606040" y="6644944"/>
-            <a:ext cx="1801368" cy="121615"/>
-          </a:xfrm>
-          <a:prstGeom prst="rect">
-            <a:avLst/>
-          </a:prstGeom>
-          <a:noFill/>
-        </p:spPr>
-        <p:txBody>
-          <a:bodyPr wrap="square">
-            <a:spAutoFit/>
-          </a:bodyPr>
-          <a:lstStyle/>
-          <a:p>
-            <a:pPr algn="ctr"/>
+            <a:off x="3410712" y="6473952"/>
+            <a:ext cx="1005840" cy="237744"/>
+          </a:xfrm>
+          <a:prstGeom prst="rect">
+            <a:avLst/>
+          </a:prstGeom>
+          <a:noFill/>
+        </p:spPr>
+        <p:txBody>
+          <a:bodyPr wrap="square">
+            <a:spAutoFit/>
+          </a:bodyPr>
+          <a:lstStyle/>
+          <a:p>
+            <a:pPr algn="l"/>
             <a:r>
               <a:rPr sz="900" b="0" i="0">
                 <a:solidFill>
@@ -18572,56 +18355,21 @@
                 </a:solidFill>
                 <a:latin typeface="Calibri Light"/>
               </a:rPr>
-              <a:t/>
-            </a:r>
-          </a:p>
-        </p:txBody>
-      </p:sp>
-      <p:sp>
-        <p:nvSpPr>
-          <p:cNvPr id="60" name="TextBox 59"/>
-          <p:cNvSpPr txBox="1"/>
-          <p:nvPr/>
-        </p:nvSpPr>
-        <p:spPr>
-          <a:xfrm>
-            <a:off x="2587752" y="6446520"/>
-            <a:ext cx="1874519" cy="274320"/>
-          </a:xfrm>
-          <a:prstGeom prst="rect">
-            <a:avLst/>
-          </a:prstGeom>
-          <a:noFill/>
-        </p:spPr>
-        <p:txBody>
-          <a:bodyPr wrap="square">
-            <a:spAutoFit/>
-          </a:bodyPr>
-          <a:lstStyle/>
-          <a:p>
-            <a:pPr algn="ctr"/>
-            <a:r>
-              <a:rPr sz="1000" b="1" i="0">
-                <a:solidFill>
-                  <a:srgbClr val="00D4FF"/>
-                </a:solidFill>
-                <a:latin typeface="Consolas"/>
-              </a:rPr>
-              <a:t>4.5h  warning window</a:t>
-            </a:r>
-          </a:p>
-        </p:txBody>
-      </p:sp>
-      <p:sp>
-        <p:nvSpPr>
-          <p:cNvPr id="61" name="Rounded Rectangle 60"/>
+              <a:t>warning window</a:t>
+            </a:r>
+          </a:p>
+        </p:txBody>
+      </p:sp>
+      <p:sp>
+        <p:nvSpPr>
+          <p:cNvPr id="59" name="Rounded Rectangle 58"/>
           <p:cNvSpPr/>
           <p:nvPr/>
         </p:nvSpPr>
         <p:spPr>
           <a:xfrm>
-            <a:off x="4617720" y="6419088"/>
-            <a:ext cx="1965960" cy="347472"/>
+            <a:off x="4617720" y="6400800"/>
+            <a:ext cx="1965960" cy="384048"/>
           </a:xfrm>
           <a:prstGeom prst="roundRect">
             <a:avLst/>
@@ -18634,13 +18382,6 @@
               <a:srgbClr val="002A44"/>
             </a:solidFill>
           </a:ln>
-          <a:effectLst>
-            <a:outerShdw blurRad="63500" dist="30000" dir="5400000" algn="ctr" rotWithShape="0">
-              <a:srgbClr val="000000">
-                <a:alpha val="28000"/>
-              </a:srgbClr>
-            </a:outerShdw>
-          </a:effectLst>
         </p:spPr>
         <p:style>
           <a:lnRef idx="1">
@@ -18666,62 +18407,62 @@
       </p:sp>
       <p:sp>
         <p:nvSpPr>
-          <p:cNvPr id="62" name="TextBox 61"/>
-          <p:cNvSpPr txBox="1"/>
-          <p:nvPr/>
-        </p:nvSpPr>
-        <p:spPr>
-          <a:xfrm>
-            <a:off x="4727448" y="6510527"/>
-            <a:ext cx="1764792" cy="215432"/>
-          </a:xfrm>
-          <a:prstGeom prst="rect">
-            <a:avLst/>
-          </a:prstGeom>
-          <a:noFill/>
-        </p:spPr>
-        <p:txBody>
-          <a:bodyPr wrap="square">
-            <a:spAutoFit/>
-          </a:bodyPr>
-          <a:lstStyle/>
-          <a:p>
-            <a:pPr algn="ctr"/>
-            <a:r>
-              <a:rPr sz="3800" b="1" i="0">
+          <p:cNvPr id="60" name="TextBox 59"/>
+          <p:cNvSpPr txBox="1"/>
+          <p:nvPr/>
+        </p:nvSpPr>
+        <p:spPr>
+          <a:xfrm>
+            <a:off x="4727448" y="6473952"/>
+            <a:ext cx="749808" cy="237744"/>
+          </a:xfrm>
+          <a:prstGeom prst="rect">
+            <a:avLst/>
+          </a:prstGeom>
+          <a:noFill/>
+        </p:spPr>
+        <p:txBody>
+          <a:bodyPr wrap="square">
+            <a:spAutoFit/>
+          </a:bodyPr>
+          <a:lstStyle/>
+          <a:p>
+            <a:pPr algn="l"/>
+            <a:r>
+              <a:rPr sz="1100" b="1" i="0">
                 <a:solidFill>
                   <a:srgbClr val="00FF88"/>
                 </a:solidFill>
                 <a:latin typeface="Consolas"/>
               </a:rPr>
-              <a:t>LIVE  Vercel + Railway</a:t>
-            </a:r>
-          </a:p>
-        </p:txBody>
-      </p:sp>
-      <p:sp>
-        <p:nvSpPr>
-          <p:cNvPr id="63" name="TextBox 62"/>
-          <p:cNvSpPr txBox="1"/>
-          <p:nvPr/>
-        </p:nvSpPr>
-        <p:spPr>
-          <a:xfrm>
-            <a:off x="4709159" y="6644944"/>
-            <a:ext cx="1801368" cy="121615"/>
-          </a:xfrm>
-          <a:prstGeom prst="rect">
-            <a:avLst/>
-          </a:prstGeom>
-          <a:noFill/>
-        </p:spPr>
-        <p:txBody>
-          <a:bodyPr wrap="square">
-            <a:spAutoFit/>
-          </a:bodyPr>
-          <a:lstStyle/>
-          <a:p>
-            <a:pPr algn="ctr"/>
+              <a:t>LIVE</a:t>
+            </a:r>
+          </a:p>
+        </p:txBody>
+      </p:sp>
+      <p:sp>
+        <p:nvSpPr>
+          <p:cNvPr id="61" name="TextBox 60"/>
+          <p:cNvSpPr txBox="1"/>
+          <p:nvPr/>
+        </p:nvSpPr>
+        <p:spPr>
+          <a:xfrm>
+            <a:off x="5513831" y="6473952"/>
+            <a:ext cx="1005840" cy="237744"/>
+          </a:xfrm>
+          <a:prstGeom prst="rect">
+            <a:avLst/>
+          </a:prstGeom>
+          <a:noFill/>
+        </p:spPr>
+        <p:txBody>
+          <a:bodyPr wrap="square">
+            <a:spAutoFit/>
+          </a:bodyPr>
+          <a:lstStyle/>
+          <a:p>
+            <a:pPr algn="l"/>
             <a:r>
               <a:rPr sz="900" b="0" i="0">
                 <a:solidFill>
@@ -18729,49 +18470,14 @@
                 </a:solidFill>
                 <a:latin typeface="Calibri Light"/>
               </a:rPr>
-              <a:t/>
-            </a:r>
-          </a:p>
-        </p:txBody>
-      </p:sp>
-      <p:sp>
-        <p:nvSpPr>
-          <p:cNvPr id="64" name="TextBox 63"/>
-          <p:cNvSpPr txBox="1"/>
-          <p:nvPr/>
-        </p:nvSpPr>
-        <p:spPr>
-          <a:xfrm>
-            <a:off x="4690872" y="6446520"/>
-            <a:ext cx="1874519" cy="274320"/>
-          </a:xfrm>
-          <a:prstGeom prst="rect">
-            <a:avLst/>
-          </a:prstGeom>
-          <a:noFill/>
-        </p:spPr>
-        <p:txBody>
-          <a:bodyPr wrap="square">
-            <a:spAutoFit/>
-          </a:bodyPr>
-          <a:lstStyle/>
-          <a:p>
-            <a:pPr algn="ctr"/>
-            <a:r>
-              <a:rPr sz="1000" b="1" i="0">
-                <a:solidFill>
-                  <a:srgbClr val="00FF88"/>
-                </a:solidFill>
-                <a:latin typeface="Consolas"/>
-              </a:rPr>
-              <a:t>LIVE  Vercel + Railway</a:t>
-            </a:r>
-          </a:p>
-        </p:txBody>
-      </p:sp>
-      <p:sp>
-        <p:nvSpPr>
-          <p:cNvPr id="65" name="Rectangle 64"/>
+              <a:t>Vercel + Railway</a:t>
+            </a:r>
+          </a:p>
+        </p:txBody>
+      </p:sp>
+      <p:sp>
+        <p:nvSpPr>
+          <p:cNvPr id="62" name="Rectangle 61"/>
           <p:cNvSpPr/>
           <p:nvPr/>
         </p:nvSpPr>

</xml_diff>